<commit_message>
refactor : Improve recommendations for unknown customers.
</commit_message>
<xml_diff>
--- a/outputs/reports/esales_presentation.pptx
+++ b/outputs/reports/esales_presentation.pptx
@@ -3058,7 +3058,7 @@
             </a:pPr>
             <a:r>
               <a:rPr lang="en-US"/>
-              <a:t>mais si un jours, les ventes britanniques s’effondrent, soudainement sur qui rebondir ?</a:t>
+              <a:t>mais si un jour, les ventes britanniques s’effondrent, soudainement sur qui rebondir ?</a:t>
             </a:r>
             <a:endParaRPr/>
           </a:p>
@@ -6235,7 +6235,7 @@
               <a:buNone/>
             </a:pPr>
             <a:r>
-              <a:rPr b="1" i="0" lang="en-US" u="none" cap="none" strike="noStrike">
+              <a:rPr b="1" lang="en-US">
                 <a:solidFill>
                   <a:srgbClr val="FFFFFF"/>
                 </a:solidFill>
@@ -6244,7 +6244,43 @@
                 <a:cs typeface="Calibri"/>
                 <a:sym typeface="Calibri"/>
               </a:rPr>
-              <a:t>Identifier les clients Unknown</a:t>
+              <a:t>Gestion</a:t>
+            </a:r>
+            <a:r>
+              <a:rPr b="1" i="0" lang="en-US" u="none" cap="none" strike="noStrike">
+                <a:solidFill>
+                  <a:srgbClr val="FFFFFF"/>
+                </a:solidFill>
+                <a:latin typeface="Calibri"/>
+                <a:ea typeface="Calibri"/>
+                <a:cs typeface="Calibri"/>
+                <a:sym typeface="Calibri"/>
+              </a:rPr>
+              <a:t> </a:t>
+            </a:r>
+            <a:r>
+              <a:rPr b="1" lang="en-US">
+                <a:solidFill>
+                  <a:srgbClr val="FFFFFF"/>
+                </a:solidFill>
+                <a:latin typeface="Calibri"/>
+                <a:ea typeface="Calibri"/>
+                <a:cs typeface="Calibri"/>
+                <a:sym typeface="Calibri"/>
+              </a:rPr>
+              <a:t>d</a:t>
+            </a:r>
+            <a:r>
+              <a:rPr b="1" i="0" lang="en-US" u="none" cap="none" strike="noStrike">
+                <a:solidFill>
+                  <a:srgbClr val="FFFFFF"/>
+                </a:solidFill>
+                <a:latin typeface="Calibri"/>
+                <a:ea typeface="Calibri"/>
+                <a:cs typeface="Calibri"/>
+                <a:sym typeface="Calibri"/>
+              </a:rPr>
+              <a:t>es clients Unknown</a:t>
             </a:r>
             <a:endParaRPr b="0" i="0" u="none" cap="none" strike="noStrike">
               <a:solidFill>
@@ -6307,7 +6343,19 @@
                 <a:cs typeface="Calibri"/>
                 <a:sym typeface="Calibri"/>
               </a:rPr>
-              <a:t>Création de compte obligatoire à la commande</a:t>
+              <a:t>C</a:t>
+            </a:r>
+            <a:r>
+              <a:rPr lang="en-US" sz="1250">
+                <a:solidFill>
+                  <a:srgbClr val="CADCFC"/>
+                </a:solidFill>
+                <a:latin typeface="Calibri"/>
+                <a:ea typeface="Calibri"/>
+                <a:cs typeface="Calibri"/>
+                <a:sym typeface="Calibri"/>
+              </a:rPr>
+              <a:t>hoisir entre : compte obligatoire - compte recommandée - avantage client</a:t>
             </a:r>
             <a:endParaRPr b="0" i="0" sz="1250" u="none" cap="none" strike="noStrike">
               <a:solidFill>
@@ -8601,7 +8649,7 @@
               <a:buNone/>
             </a:pPr>
             <a:r>
-              <a:rPr b="0" i="0" lang="en-US" sz="1400" u="none" cap="none" strike="noStrike">
+              <a:rPr lang="en-US">
                 <a:solidFill>
                   <a:srgbClr val="FFFFFF"/>
                 </a:solidFill>
@@ -8610,31 +8658,7 @@
                 <a:cs typeface="Calibri"/>
                 <a:sym typeface="Calibri"/>
               </a:rPr>
-              <a:t>Identifier les clients Unknown </a:t>
-            </a:r>
-            <a:r>
-              <a:rPr lang="en-US">
-                <a:solidFill>
-                  <a:srgbClr val="FFFFFF"/>
-                </a:solidFill>
-                <a:latin typeface="Calibri"/>
-                <a:ea typeface="Calibri"/>
-                <a:cs typeface="Calibri"/>
-                <a:sym typeface="Calibri"/>
-              </a:rPr>
-              <a:t>avec une</a:t>
-            </a:r>
-            <a:r>
-              <a:rPr b="0" i="0" lang="en-US" sz="1400" u="none" cap="none" strike="noStrike">
-                <a:solidFill>
-                  <a:srgbClr val="FFFFFF"/>
-                </a:solidFill>
-                <a:latin typeface="Calibri"/>
-                <a:ea typeface="Calibri"/>
-                <a:cs typeface="Calibri"/>
-                <a:sym typeface="Calibri"/>
-              </a:rPr>
-              <a:t> création de compte obligatoire</a:t>
+              <a:t>Equilibre entre identification des clients anonymes et risques acceptables</a:t>
             </a:r>
             <a:endParaRPr b="0" i="0" sz="1400" u="none" cap="none" strike="noStrike">
               <a:solidFill>
@@ -9553,7 +9577,7 @@
           <a:effectLst>
             <a:outerShdw blurRad="101600" rotWithShape="0" algn="bl" dir="2700000" dist="25400">
               <a:srgbClr val="000000">
-                <a:alpha val="10200"/>
+                <a:alpha val="10199"/>
               </a:srgbClr>
             </a:outerShdw>
           </a:effectLst>
@@ -9842,7 +9866,7 @@
           <a:effectLst>
             <a:outerShdw blurRad="101600" rotWithShape="0" algn="bl" dir="2700000" dist="25400">
               <a:srgbClr val="000000">
-                <a:alpha val="10200"/>
+                <a:alpha val="10199"/>
               </a:srgbClr>
             </a:outerShdw>
           </a:effectLst>
@@ -10744,7 +10768,7 @@
           <a:effectLst>
             <a:outerShdw blurRad="101600" rotWithShape="0" algn="bl" dir="2700000" dist="25400">
               <a:srgbClr val="000000">
-                <a:alpha val="10200"/>
+                <a:alpha val="10199"/>
               </a:srgbClr>
             </a:outerShdw>
           </a:effectLst>
@@ -11028,7 +11052,31 @@
                 <a:cs typeface="Calibri"/>
                 <a:sym typeface="Calibri"/>
               </a:rPr>
-              <a:t>Action · Rendre la création de compte obligatoire à la commande — identifier et fidéliser votre meilleur segment.</a:t>
+              <a:t>Action </a:t>
+            </a:r>
+            <a:r>
+              <a:rPr lang="en-US" sz="1300">
+                <a:solidFill>
+                  <a:srgbClr val="FFFFFF"/>
+                </a:solidFill>
+                <a:latin typeface="Calibri"/>
+                <a:ea typeface="Calibri"/>
+                <a:cs typeface="Calibri"/>
+                <a:sym typeface="Calibri"/>
+              </a:rPr>
+              <a:t>: Gérer l’identification des clients anonymes  et </a:t>
+            </a:r>
+            <a:r>
+              <a:rPr b="0" i="0" lang="en-US" sz="1300" u="none" cap="none" strike="noStrike">
+                <a:solidFill>
+                  <a:srgbClr val="FFFFFF"/>
+                </a:solidFill>
+                <a:latin typeface="Calibri"/>
+                <a:ea typeface="Calibri"/>
+                <a:cs typeface="Calibri"/>
+                <a:sym typeface="Calibri"/>
+              </a:rPr>
+              <a:t>fidéliser votre meilleur segment.</a:t>
             </a:r>
             <a:endParaRPr b="0" i="0" sz="1300" u="none" cap="none" strike="noStrike">
               <a:solidFill>
@@ -11123,7 +11171,7 @@
           <a:effectLst>
             <a:outerShdw blurRad="101600" rotWithShape="0" algn="bl" dir="2700000" dist="25400">
               <a:srgbClr val="000000">
-                <a:alpha val="10200"/>
+                <a:alpha val="10199"/>
               </a:srgbClr>
             </a:outerShdw>
           </a:effectLst>

</xml_diff>